<commit_message>
Ultima version del powerpoint
</commit_message>
<xml_diff>
--- a/tp-fabrica.pptx
+++ b/tp-fabrica.pptx
@@ -12,8 +12,11 @@
     <p:sldId id="260" r:id="rId6"/>
     <p:sldId id="261" r:id="rId7"/>
     <p:sldId id="262" r:id="rId8"/>
-    <p:sldId id="263" r:id="rId9"/>
-    <p:sldId id="264" r:id="rId10"/>
+    <p:sldId id="264" r:id="rId9"/>
+    <p:sldId id="265" r:id="rId10"/>
+    <p:sldId id="266" r:id="rId11"/>
+    <p:sldId id="267" r:id="rId12"/>
+    <p:sldId id="263" r:id="rId13"/>
   </p:sldIdLst>
   <p:sldSz cx="9144000" cy="6858000" type="screen4x3"/>
   <p:notesSz cx="6858000" cy="9144000"/>
@@ -26689,6 +26692,554 @@
 </p:sld>
 </file>
 
+<file path=ppt/slides/slide10.xml><?xml version="1.0" encoding="utf-8"?>
+<p:sld xmlns:a="http://schemas.openxmlformats.org/drawingml/2006/main" xmlns:r="http://schemas.openxmlformats.org/officeDocument/2006/relationships" xmlns:p="http://schemas.openxmlformats.org/presentationml/2006/main">
+  <p:cSld>
+    <p:spTree>
+      <p:nvGrpSpPr>
+        <p:cNvPr id="1" name=""/>
+        <p:cNvGrpSpPr/>
+        <p:nvPr/>
+      </p:nvGrpSpPr>
+      <p:grpSpPr>
+        <a:xfrm>
+          <a:off x="0" y="0"/>
+          <a:ext cx="0" cy="0"/>
+          <a:chOff x="0" y="0"/>
+          <a:chExt cx="0" cy="0"/>
+        </a:xfrm>
+      </p:grpSpPr>
+      <p:pic>
+        <p:nvPicPr>
+          <p:cNvPr id="5" name="Marcador de contenido 4">
+            <a:extLst>
+              <a:ext uri="{FF2B5EF4-FFF2-40B4-BE49-F238E27FC236}">
+                <a16:creationId xmlns:a16="http://schemas.microsoft.com/office/drawing/2014/main" id="{1C2B9B2E-400C-8F84-C05A-472351CD06AD}"/>
+              </a:ext>
+            </a:extLst>
+          </p:cNvPr>
+          <p:cNvPicPr>
+            <a:picLocks noGrp="1" noChangeAspect="1"/>
+          </p:cNvPicPr>
+          <p:nvPr>
+            <p:ph idx="1"/>
+          </p:nvPr>
+        </p:nvPicPr>
+        <p:blipFill>
+          <a:blip r:embed="rId2"/>
+          <a:stretch>
+            <a:fillRect/>
+          </a:stretch>
+        </p:blipFill>
+        <p:spPr>
+          <a:xfrm>
+            <a:off x="2047874" y="579019"/>
+            <a:ext cx="6143625" cy="2343150"/>
+          </a:xfrm>
+          <a:prstGeom prst="rect">
+            <a:avLst/>
+          </a:prstGeom>
+        </p:spPr>
+      </p:pic>
+      <p:pic>
+        <p:nvPicPr>
+          <p:cNvPr id="7" name="Imagen 6">
+            <a:extLst>
+              <a:ext uri="{FF2B5EF4-FFF2-40B4-BE49-F238E27FC236}">
+                <a16:creationId xmlns:a16="http://schemas.microsoft.com/office/drawing/2014/main" id="{6F9698AA-1AE8-D52F-84E0-93639D002928}"/>
+              </a:ext>
+            </a:extLst>
+          </p:cNvPr>
+          <p:cNvPicPr>
+            <a:picLocks noChangeAspect="1"/>
+          </p:cNvPicPr>
+          <p:nvPr/>
+        </p:nvPicPr>
+        <p:blipFill>
+          <a:blip r:embed="rId3"/>
+          <a:stretch>
+            <a:fillRect/>
+          </a:stretch>
+        </p:blipFill>
+        <p:spPr>
+          <a:xfrm>
+            <a:off x="1486401" y="3066548"/>
+            <a:ext cx="5886450" cy="2362200"/>
+          </a:xfrm>
+          <a:prstGeom prst="rect">
+            <a:avLst/>
+          </a:prstGeom>
+        </p:spPr>
+      </p:pic>
+    </p:spTree>
+    <p:extLst>
+      <p:ext uri="{BB962C8B-B14F-4D97-AF65-F5344CB8AC3E}">
+        <p14:creationId xmlns:p14="http://schemas.microsoft.com/office/powerpoint/2010/main" val="3777206299"/>
+      </p:ext>
+    </p:extLst>
+  </p:cSld>
+  <p:clrMapOvr>
+    <a:masterClrMapping/>
+  </p:clrMapOvr>
+</p:sld>
+</file>
+
+<file path=ppt/slides/slide11.xml><?xml version="1.0" encoding="utf-8"?>
+<p:sld xmlns:a="http://schemas.openxmlformats.org/drawingml/2006/main" xmlns:r="http://schemas.openxmlformats.org/officeDocument/2006/relationships" xmlns:p="http://schemas.openxmlformats.org/presentationml/2006/main">
+  <p:cSld>
+    <p:spTree>
+      <p:nvGrpSpPr>
+        <p:cNvPr id="1" name=""/>
+        <p:cNvGrpSpPr/>
+        <p:nvPr/>
+      </p:nvGrpSpPr>
+      <p:grpSpPr>
+        <a:xfrm>
+          <a:off x="0" y="0"/>
+          <a:ext cx="0" cy="0"/>
+          <a:chOff x="0" y="0"/>
+          <a:chExt cx="0" cy="0"/>
+        </a:xfrm>
+      </p:grpSpPr>
+      <p:pic>
+        <p:nvPicPr>
+          <p:cNvPr id="1026" name="Picture 2">
+            <a:extLst>
+              <a:ext uri="{FF2B5EF4-FFF2-40B4-BE49-F238E27FC236}">
+                <a16:creationId xmlns:a16="http://schemas.microsoft.com/office/drawing/2014/main" id="{2B9AF9FB-DC91-8387-05C9-2414A47BB45B}"/>
+              </a:ext>
+            </a:extLst>
+          </p:cNvPr>
+          <p:cNvPicPr>
+            <a:picLocks noChangeAspect="1" noChangeArrowheads="1"/>
+          </p:cNvPicPr>
+          <p:nvPr/>
+        </p:nvPicPr>
+        <p:blipFill>
+          <a:blip r:embed="rId2">
+            <a:extLst>
+              <a:ext uri="{28A0092B-C50C-407E-A947-70E740481C1C}">
+                <a14:useLocalDpi xmlns:a14="http://schemas.microsoft.com/office/drawing/2010/main" val="0"/>
+              </a:ext>
+            </a:extLst>
+          </a:blip>
+          <a:srcRect/>
+          <a:stretch>
+            <a:fillRect/>
+          </a:stretch>
+        </p:blipFill>
+        <p:spPr bwMode="auto">
+          <a:xfrm>
+            <a:off x="229352" y="283110"/>
+            <a:ext cx="5600700" cy="3267075"/>
+          </a:xfrm>
+          <a:prstGeom prst="rect">
+            <a:avLst/>
+          </a:prstGeom>
+          <a:noFill/>
+          <a:ln>
+            <a:noFill/>
+          </a:ln>
+          <a:extLst>
+            <a:ext uri="{909E8E84-426E-40DD-AFC4-6F175D3DCCD1}">
+              <a14:hiddenFill xmlns:a14="http://schemas.microsoft.com/office/drawing/2010/main">
+                <a:solidFill>
+                  <a:srgbClr val="FFFFFF"/>
+                </a:solidFill>
+              </a14:hiddenFill>
+            </a:ext>
+            <a:ext uri="{91240B29-F687-4F45-9708-019B960494DF}">
+              <a14:hiddenLine xmlns:a14="http://schemas.microsoft.com/office/drawing/2010/main" w="9525">
+                <a:solidFill>
+                  <a:srgbClr val="000000"/>
+                </a:solidFill>
+                <a:miter lim="800000"/>
+                <a:headEnd/>
+                <a:tailEnd/>
+              </a14:hiddenLine>
+            </a:ext>
+          </a:extLst>
+        </p:spPr>
+      </p:pic>
+      <p:pic>
+        <p:nvPicPr>
+          <p:cNvPr id="5" name="Imagen 4">
+            <a:extLst>
+              <a:ext uri="{FF2B5EF4-FFF2-40B4-BE49-F238E27FC236}">
+                <a16:creationId xmlns:a16="http://schemas.microsoft.com/office/drawing/2014/main" id="{E150931E-D92E-EFB8-8A8F-2AF06C911934}"/>
+              </a:ext>
+            </a:extLst>
+          </p:cNvPr>
+          <p:cNvPicPr>
+            <a:picLocks noChangeAspect="1"/>
+          </p:cNvPicPr>
+          <p:nvPr/>
+        </p:nvPicPr>
+        <p:blipFill>
+          <a:blip r:embed="rId3"/>
+          <a:stretch>
+            <a:fillRect/>
+          </a:stretch>
+        </p:blipFill>
+        <p:spPr>
+          <a:xfrm>
+            <a:off x="1716502" y="3868402"/>
+            <a:ext cx="6711111" cy="2706488"/>
+          </a:xfrm>
+          <a:prstGeom prst="rect">
+            <a:avLst/>
+          </a:prstGeom>
+        </p:spPr>
+      </p:pic>
+    </p:spTree>
+    <p:extLst>
+      <p:ext uri="{BB962C8B-B14F-4D97-AF65-F5344CB8AC3E}">
+        <p14:creationId xmlns:p14="http://schemas.microsoft.com/office/powerpoint/2010/main" val="2128709654"/>
+      </p:ext>
+    </p:extLst>
+  </p:cSld>
+  <p:clrMapOvr>
+    <a:masterClrMapping/>
+  </p:clrMapOvr>
+</p:sld>
+</file>
+
+<file path=ppt/slides/slide12.xml><?xml version="1.0" encoding="utf-8"?>
+<p:sld xmlns:a="http://schemas.openxmlformats.org/drawingml/2006/main" xmlns:r="http://schemas.openxmlformats.org/officeDocument/2006/relationships" xmlns:p="http://schemas.openxmlformats.org/presentationml/2006/main">
+  <p:cSld>
+    <p:bg>
+      <p:bgPr>
+        <a:solidFill>
+          <a:schemeClr val="bg1"/>
+        </a:solidFill>
+        <a:effectLst/>
+      </p:bgPr>
+    </p:bg>
+    <p:spTree>
+      <p:nvGrpSpPr>
+        <p:cNvPr id="1" name=""/>
+        <p:cNvGrpSpPr/>
+        <p:nvPr/>
+      </p:nvGrpSpPr>
+      <p:grpSpPr>
+        <a:xfrm>
+          <a:off x="0" y="0"/>
+          <a:ext cx="0" cy="0"/>
+          <a:chOff x="0" y="0"/>
+          <a:chExt cx="0" cy="0"/>
+        </a:xfrm>
+      </p:grpSpPr>
+      <p:sp>
+        <p:nvSpPr>
+          <p:cNvPr id="8" name="Rounded Rectangle 14">
+            <a:extLst>
+              <a:ext uri="{FF2B5EF4-FFF2-40B4-BE49-F238E27FC236}">
+                <a16:creationId xmlns:a16="http://schemas.microsoft.com/office/drawing/2014/main" id="{637BD688-14A6-4B96-B8A2-3CD81C054FCE}"/>
+              </a:ext>
+              <a:ext uri="{C183D7F6-B498-43B3-948B-1728B52AA6E4}">
+                <adec:decorative xmlns:adec="http://schemas.microsoft.com/office/drawing/2017/decorative" val="1"/>
+              </a:ext>
+            </a:extLst>
+          </p:cNvPr>
+          <p:cNvSpPr>
+            <a:spLocks noGrp="1" noRot="1" noChangeAspect="1" noMove="1" noResize="1" noEditPoints="1" noAdjustHandles="1" noChangeArrowheads="1" noChangeShapeType="1" noTextEdit="1"/>
+          </p:cNvSpPr>
+          <p:nvPr>
+            <p:extLst>
+              <p:ext uri="{386F3935-93C4-4BCD-93E2-E3B085C9AB24}">
+                <p16:designElem xmlns:p16="http://schemas.microsoft.com/office/powerpoint/2015/main" val="1"/>
+              </p:ext>
+            </p:extLst>
+          </p:nvPr>
+        </p:nvSpPr>
+        <p:spPr>
+          <a:xfrm>
+            <a:off x="3477006" y="0"/>
+            <a:ext cx="5666994" cy="6858000"/>
+          </a:xfrm>
+          <a:prstGeom prst="rect">
+            <a:avLst/>
+          </a:prstGeom>
+          <a:solidFill>
+            <a:schemeClr val="bg2"/>
+          </a:solidFill>
+          <a:ln>
+            <a:noFill/>
+          </a:ln>
+          <a:effectLst/>
+        </p:spPr>
+        <p:style>
+          <a:lnRef idx="2">
+            <a:schemeClr val="accent1">
+              <a:shade val="50000"/>
+            </a:schemeClr>
+          </a:lnRef>
+          <a:fillRef idx="1">
+            <a:schemeClr val="accent1"/>
+          </a:fillRef>
+          <a:effectRef idx="0">
+            <a:schemeClr val="accent1"/>
+          </a:effectRef>
+          <a:fontRef idx="minor">
+            <a:schemeClr val="lt1"/>
+          </a:fontRef>
+        </p:style>
+        <p:txBody>
+          <a:bodyPr rtlCol="0" anchor="ctr"/>
+          <a:lstStyle/>
+          <a:p>
+            <a:pPr marL="0" marR="0" lvl="0" indent="0" algn="ctr" defTabSz="457200" rtl="0" eaLnBrk="1" fontAlgn="auto" latinLnBrk="0" hangingPunct="1">
+              <a:lnSpc>
+                <a:spcPct val="100000"/>
+              </a:lnSpc>
+              <a:spcBef>
+                <a:spcPts val="0"/>
+              </a:spcBef>
+              <a:spcAft>
+                <a:spcPts val="0"/>
+              </a:spcAft>
+              <a:buClrTx/>
+              <a:buSzTx/>
+              <a:buFontTx/>
+              <a:buNone/>
+              <a:tabLst/>
+              <a:defRPr/>
+            </a:pPr>
+            <a:endParaRPr kumimoji="0" lang="en-US" sz="1800" b="0" i="0" u="none" strike="noStrike" kern="1200" cap="none" spc="0" normalizeH="0" baseline="0" noProof="0">
+              <a:ln>
+                <a:noFill/>
+              </a:ln>
+              <a:solidFill>
+                <a:prstClr val="white"/>
+              </a:solidFill>
+              <a:effectLst/>
+              <a:uLnTx/>
+              <a:uFillTx/>
+              <a:latin typeface="Century Gothic" panose="020B0502020202020204"/>
+              <a:ea typeface="+mn-ea"/>
+              <a:cs typeface="+mn-cs"/>
+            </a:endParaRPr>
+          </a:p>
+        </p:txBody>
+      </p:sp>
+      <p:sp useBgFill="1">
+        <p:nvSpPr>
+          <p:cNvPr id="10" name="Rectangle 9">
+            <a:extLst>
+              <a:ext uri="{FF2B5EF4-FFF2-40B4-BE49-F238E27FC236}">
+                <a16:creationId xmlns:a16="http://schemas.microsoft.com/office/drawing/2014/main" id="{B7B2544F-CA5E-40F6-9525-716A90C83FC5}"/>
+              </a:ext>
+              <a:ext uri="{C183D7F6-B498-43B3-948B-1728B52AA6E4}">
+                <adec:decorative xmlns:adec="http://schemas.microsoft.com/office/drawing/2017/decorative" val="1"/>
+              </a:ext>
+            </a:extLst>
+          </p:cNvPr>
+          <p:cNvSpPr>
+            <a:spLocks noGrp="1" noRot="1" noChangeAspect="1" noMove="1" noResize="1" noEditPoints="1" noAdjustHandles="1" noChangeArrowheads="1" noChangeShapeType="1" noTextEdit="1"/>
+          </p:cNvSpPr>
+          <p:nvPr>
+            <p:extLst>
+              <p:ext uri="{386F3935-93C4-4BCD-93E2-E3B085C9AB24}">
+                <p16:designElem xmlns:p16="http://schemas.microsoft.com/office/powerpoint/2015/main" val="1"/>
+              </p:ext>
+            </p:extLst>
+          </p:nvPr>
+        </p:nvSpPr>
+        <p:spPr>
+          <a:xfrm>
+            <a:off x="0" y="0"/>
+            <a:ext cx="3477006" cy="6858000"/>
+          </a:xfrm>
+          <a:prstGeom prst="rect">
+            <a:avLst/>
+          </a:prstGeom>
+          <a:ln>
+            <a:noFill/>
+          </a:ln>
+          <a:effectLst>
+            <a:outerShdw blurRad="63500" dist="38100" algn="l" rotWithShape="0">
+              <a:prstClr val="black">
+                <a:alpha val="40000"/>
+              </a:prstClr>
+            </a:outerShdw>
+          </a:effectLst>
+        </p:spPr>
+        <p:style>
+          <a:lnRef idx="2">
+            <a:schemeClr val="accent1">
+              <a:shade val="50000"/>
+            </a:schemeClr>
+          </a:lnRef>
+          <a:fillRef idx="1">
+            <a:schemeClr val="accent1"/>
+          </a:fillRef>
+          <a:effectRef idx="0">
+            <a:schemeClr val="accent1"/>
+          </a:effectRef>
+          <a:fontRef idx="minor">
+            <a:schemeClr val="lt1"/>
+          </a:fontRef>
+        </p:style>
+        <p:txBody>
+          <a:bodyPr rtlCol="0" anchor="ctr"/>
+          <a:lstStyle/>
+          <a:p>
+            <a:pPr marL="0" marR="0" lvl="0" indent="0" algn="ctr" defTabSz="457200" rtl="0" eaLnBrk="1" fontAlgn="auto" latinLnBrk="0" hangingPunct="1">
+              <a:lnSpc>
+                <a:spcPct val="100000"/>
+              </a:lnSpc>
+              <a:spcBef>
+                <a:spcPts val="0"/>
+              </a:spcBef>
+              <a:spcAft>
+                <a:spcPts val="0"/>
+              </a:spcAft>
+              <a:buClrTx/>
+              <a:buSzTx/>
+              <a:buFontTx/>
+              <a:buNone/>
+              <a:tabLst/>
+              <a:defRPr/>
+            </a:pPr>
+            <a:endParaRPr kumimoji="0" lang="en-US" sz="1800" b="0" i="0" u="none" strike="noStrike" kern="1200" cap="none" spc="0" normalizeH="0" baseline="0" noProof="0">
+              <a:ln>
+                <a:noFill/>
+              </a:ln>
+              <a:solidFill>
+                <a:prstClr val="white"/>
+              </a:solidFill>
+              <a:effectLst/>
+              <a:uLnTx/>
+              <a:uFillTx/>
+              <a:latin typeface="Century Gothic" panose="020B0502020202020204"/>
+              <a:ea typeface="+mn-ea"/>
+              <a:cs typeface="+mn-cs"/>
+            </a:endParaRPr>
+          </a:p>
+        </p:txBody>
+      </p:sp>
+      <p:pic>
+        <p:nvPicPr>
+          <p:cNvPr id="12" name="Picture 11">
+            <a:extLst>
+              <a:ext uri="{FF2B5EF4-FFF2-40B4-BE49-F238E27FC236}">
+                <a16:creationId xmlns:a16="http://schemas.microsoft.com/office/drawing/2014/main" id="{D2B93162-635C-46F5-97EC-E98C1659F1F0}"/>
+              </a:ext>
+              <a:ext uri="{C183D7F6-B498-43B3-948B-1728B52AA6E4}">
+                <adec:decorative xmlns:adec="http://schemas.microsoft.com/office/drawing/2017/decorative" val="1"/>
+              </a:ext>
+            </a:extLst>
+          </p:cNvPr>
+          <p:cNvPicPr>
+            <a:picLocks noGrp="1" noRot="1" noChangeAspect="1" noMove="1" noResize="1" noEditPoints="1" noAdjustHandles="1" noChangeArrowheads="1" noChangeShapeType="1" noCrop="1"/>
+          </p:cNvPicPr>
+          <p:nvPr>
+            <p:extLst>
+              <p:ext uri="{386F3935-93C4-4BCD-93E2-E3B085C9AB24}">
+                <p16:designElem xmlns:p16="http://schemas.microsoft.com/office/powerpoint/2015/main" val="1"/>
+              </p:ext>
+            </p:extLst>
+          </p:nvPr>
+        </p:nvPicPr>
+        <p:blipFill rotWithShape="1">
+          <a:blip r:embed="rId2">
+            <a:extLst>
+              <a:ext uri="{28A0092B-C50C-407E-A947-70E740481C1C}">
+                <a14:useLocalDpi xmlns:a14="http://schemas.microsoft.com/office/drawing/2010/main" val="0"/>
+              </a:ext>
+            </a:extLst>
+          </a:blip>
+          <a:srcRect r="61975"/>
+          <a:stretch/>
+        </p:blipFill>
+        <p:spPr>
+          <a:xfrm>
+            <a:off x="0" y="4375150"/>
+            <a:ext cx="3477006" cy="2482850"/>
+          </a:xfrm>
+          <a:prstGeom prst="rect">
+            <a:avLst/>
+          </a:prstGeom>
+        </p:spPr>
+      </p:pic>
+      <p:sp>
+        <p:nvSpPr>
+          <p:cNvPr id="2" name="Title 1"/>
+          <p:cNvSpPr>
+            <a:spLocks noGrp="1"/>
+          </p:cNvSpPr>
+          <p:nvPr>
+            <p:ph type="title"/>
+          </p:nvPr>
+        </p:nvSpPr>
+        <p:spPr>
+          <a:xfrm>
+            <a:off x="499441" y="987287"/>
+            <a:ext cx="2661202" cy="4697896"/>
+          </a:xfrm>
+        </p:spPr>
+        <p:txBody>
+          <a:bodyPr>
+            <a:normAutofit/>
+          </a:bodyPr>
+          <a:lstStyle/>
+          <a:p>
+            <a:r>
+              <a:rPr lang="es-AR" sz="2900"/>
+              <a:t>Conclusión</a:t>
+            </a:r>
+          </a:p>
+        </p:txBody>
+      </p:sp>
+      <p:sp>
+        <p:nvSpPr>
+          <p:cNvPr id="3" name="Content Placeholder 2"/>
+          <p:cNvSpPr>
+            <a:spLocks noGrp="1"/>
+          </p:cNvSpPr>
+          <p:nvPr>
+            <p:ph idx="1"/>
+          </p:nvPr>
+        </p:nvSpPr>
+        <p:spPr>
+          <a:xfrm>
+            <a:off x="3793368" y="987287"/>
+            <a:ext cx="4316962" cy="4697895"/>
+          </a:xfrm>
+        </p:spPr>
+        <p:txBody>
+          <a:bodyPr anchor="ctr">
+            <a:normAutofit/>
+          </a:bodyPr>
+          <a:lstStyle/>
+          <a:p>
+            <a:r>
+              <a:rPr lang="es-ES" sz="1600"/>
+              <a:t>• Se logró modelar el funcionamiento completo de una fábrica automotriz.</a:t>
+            </a:r>
+          </a:p>
+          <a:p>
+            <a:r>
+              <a:rPr lang="es-ES" sz="1600"/>
+              <a:t>• Se aplicaron conceptos de bases de datos, ABM y consultas SQL.</a:t>
+            </a:r>
+          </a:p>
+          <a:p>
+            <a:r>
+              <a:rPr lang="es-ES" sz="1600"/>
+              <a:t>• Buen trabajo en equipo entre Word, SQL y PowerPoint.</a:t>
+            </a:r>
+          </a:p>
+        </p:txBody>
+      </p:sp>
+    </p:spTree>
+  </p:cSld>
+  <p:clrMapOvr>
+    <a:masterClrMapping/>
+  </p:clrMapOvr>
+</p:sld>
+</file>
+
 <file path=ppt/slides/slide2.xml><?xml version="1.0" encoding="utf-8"?>
 <p:sld xmlns:a="http://schemas.openxmlformats.org/drawingml/2006/main" xmlns:r="http://schemas.openxmlformats.org/officeDocument/2006/relationships" xmlns:p="http://schemas.openxmlformats.org/presentationml/2006/main">
   <p:cSld>
@@ -27474,342 +28025,6 @@
 <file path=ppt/slides/slide8.xml><?xml version="1.0" encoding="utf-8"?>
 <p:sld xmlns:a="http://schemas.openxmlformats.org/drawingml/2006/main" xmlns:r="http://schemas.openxmlformats.org/officeDocument/2006/relationships" xmlns:p="http://schemas.openxmlformats.org/presentationml/2006/main">
   <p:cSld>
-    <p:bg>
-      <p:bgPr>
-        <a:solidFill>
-          <a:schemeClr val="bg1"/>
-        </a:solidFill>
-        <a:effectLst/>
-      </p:bgPr>
-    </p:bg>
-    <p:spTree>
-      <p:nvGrpSpPr>
-        <p:cNvPr id="1" name=""/>
-        <p:cNvGrpSpPr/>
-        <p:nvPr/>
-      </p:nvGrpSpPr>
-      <p:grpSpPr>
-        <a:xfrm>
-          <a:off x="0" y="0"/>
-          <a:ext cx="0" cy="0"/>
-          <a:chOff x="0" y="0"/>
-          <a:chExt cx="0" cy="0"/>
-        </a:xfrm>
-      </p:grpSpPr>
-      <p:sp>
-        <p:nvSpPr>
-          <p:cNvPr id="8" name="Rounded Rectangle 14">
-            <a:extLst>
-              <a:ext uri="{FF2B5EF4-FFF2-40B4-BE49-F238E27FC236}">
-                <a16:creationId xmlns:a16="http://schemas.microsoft.com/office/drawing/2014/main" id="{637BD688-14A6-4B96-B8A2-3CD81C054FCE}"/>
-              </a:ext>
-              <a:ext uri="{C183D7F6-B498-43B3-948B-1728B52AA6E4}">
-                <adec:decorative xmlns:adec="http://schemas.microsoft.com/office/drawing/2017/decorative" val="1"/>
-              </a:ext>
-            </a:extLst>
-          </p:cNvPr>
-          <p:cNvSpPr>
-            <a:spLocks noGrp="1" noRot="1" noChangeAspect="1" noMove="1" noResize="1" noEditPoints="1" noAdjustHandles="1" noChangeArrowheads="1" noChangeShapeType="1" noTextEdit="1"/>
-          </p:cNvSpPr>
-          <p:nvPr>
-            <p:extLst>
-              <p:ext uri="{386F3935-93C4-4BCD-93E2-E3B085C9AB24}">
-                <p16:designElem xmlns:p16="http://schemas.microsoft.com/office/powerpoint/2015/main" val="1"/>
-              </p:ext>
-            </p:extLst>
-          </p:nvPr>
-        </p:nvSpPr>
-        <p:spPr>
-          <a:xfrm>
-            <a:off x="3477006" y="0"/>
-            <a:ext cx="5666994" cy="6858000"/>
-          </a:xfrm>
-          <a:prstGeom prst="rect">
-            <a:avLst/>
-          </a:prstGeom>
-          <a:solidFill>
-            <a:schemeClr val="bg2"/>
-          </a:solidFill>
-          <a:ln>
-            <a:noFill/>
-          </a:ln>
-          <a:effectLst/>
-        </p:spPr>
-        <p:style>
-          <a:lnRef idx="2">
-            <a:schemeClr val="accent1">
-              <a:shade val="50000"/>
-            </a:schemeClr>
-          </a:lnRef>
-          <a:fillRef idx="1">
-            <a:schemeClr val="accent1"/>
-          </a:fillRef>
-          <a:effectRef idx="0">
-            <a:schemeClr val="accent1"/>
-          </a:effectRef>
-          <a:fontRef idx="minor">
-            <a:schemeClr val="lt1"/>
-          </a:fontRef>
-        </p:style>
-        <p:txBody>
-          <a:bodyPr rtlCol="0" anchor="ctr"/>
-          <a:lstStyle/>
-          <a:p>
-            <a:pPr marL="0" marR="0" lvl="0" indent="0" algn="ctr" defTabSz="457200" rtl="0" eaLnBrk="1" fontAlgn="auto" latinLnBrk="0" hangingPunct="1">
-              <a:lnSpc>
-                <a:spcPct val="100000"/>
-              </a:lnSpc>
-              <a:spcBef>
-                <a:spcPts val="0"/>
-              </a:spcBef>
-              <a:spcAft>
-                <a:spcPts val="0"/>
-              </a:spcAft>
-              <a:buClrTx/>
-              <a:buSzTx/>
-              <a:buFontTx/>
-              <a:buNone/>
-              <a:tabLst/>
-              <a:defRPr/>
-            </a:pPr>
-            <a:endParaRPr kumimoji="0" lang="en-US" sz="1800" b="0" i="0" u="none" strike="noStrike" kern="1200" cap="none" spc="0" normalizeH="0" baseline="0" noProof="0">
-              <a:ln>
-                <a:noFill/>
-              </a:ln>
-              <a:solidFill>
-                <a:prstClr val="white"/>
-              </a:solidFill>
-              <a:effectLst/>
-              <a:uLnTx/>
-              <a:uFillTx/>
-              <a:latin typeface="Century Gothic" panose="020B0502020202020204"/>
-              <a:ea typeface="+mn-ea"/>
-              <a:cs typeface="+mn-cs"/>
-            </a:endParaRPr>
-          </a:p>
-        </p:txBody>
-      </p:sp>
-      <p:sp useBgFill="1">
-        <p:nvSpPr>
-          <p:cNvPr id="10" name="Rectangle 9">
-            <a:extLst>
-              <a:ext uri="{FF2B5EF4-FFF2-40B4-BE49-F238E27FC236}">
-                <a16:creationId xmlns:a16="http://schemas.microsoft.com/office/drawing/2014/main" id="{B7B2544F-CA5E-40F6-9525-716A90C83FC5}"/>
-              </a:ext>
-              <a:ext uri="{C183D7F6-B498-43B3-948B-1728B52AA6E4}">
-                <adec:decorative xmlns:adec="http://schemas.microsoft.com/office/drawing/2017/decorative" val="1"/>
-              </a:ext>
-            </a:extLst>
-          </p:cNvPr>
-          <p:cNvSpPr>
-            <a:spLocks noGrp="1" noRot="1" noChangeAspect="1" noMove="1" noResize="1" noEditPoints="1" noAdjustHandles="1" noChangeArrowheads="1" noChangeShapeType="1" noTextEdit="1"/>
-          </p:cNvSpPr>
-          <p:nvPr>
-            <p:extLst>
-              <p:ext uri="{386F3935-93C4-4BCD-93E2-E3B085C9AB24}">
-                <p16:designElem xmlns:p16="http://schemas.microsoft.com/office/powerpoint/2015/main" val="1"/>
-              </p:ext>
-            </p:extLst>
-          </p:nvPr>
-        </p:nvSpPr>
-        <p:spPr>
-          <a:xfrm>
-            <a:off x="0" y="0"/>
-            <a:ext cx="3477006" cy="6858000"/>
-          </a:xfrm>
-          <a:prstGeom prst="rect">
-            <a:avLst/>
-          </a:prstGeom>
-          <a:ln>
-            <a:noFill/>
-          </a:ln>
-          <a:effectLst>
-            <a:outerShdw blurRad="63500" dist="38100" algn="l" rotWithShape="0">
-              <a:prstClr val="black">
-                <a:alpha val="40000"/>
-              </a:prstClr>
-            </a:outerShdw>
-          </a:effectLst>
-        </p:spPr>
-        <p:style>
-          <a:lnRef idx="2">
-            <a:schemeClr val="accent1">
-              <a:shade val="50000"/>
-            </a:schemeClr>
-          </a:lnRef>
-          <a:fillRef idx="1">
-            <a:schemeClr val="accent1"/>
-          </a:fillRef>
-          <a:effectRef idx="0">
-            <a:schemeClr val="accent1"/>
-          </a:effectRef>
-          <a:fontRef idx="minor">
-            <a:schemeClr val="lt1"/>
-          </a:fontRef>
-        </p:style>
-        <p:txBody>
-          <a:bodyPr rtlCol="0" anchor="ctr"/>
-          <a:lstStyle/>
-          <a:p>
-            <a:pPr marL="0" marR="0" lvl="0" indent="0" algn="ctr" defTabSz="457200" rtl="0" eaLnBrk="1" fontAlgn="auto" latinLnBrk="0" hangingPunct="1">
-              <a:lnSpc>
-                <a:spcPct val="100000"/>
-              </a:lnSpc>
-              <a:spcBef>
-                <a:spcPts val="0"/>
-              </a:spcBef>
-              <a:spcAft>
-                <a:spcPts val="0"/>
-              </a:spcAft>
-              <a:buClrTx/>
-              <a:buSzTx/>
-              <a:buFontTx/>
-              <a:buNone/>
-              <a:tabLst/>
-              <a:defRPr/>
-            </a:pPr>
-            <a:endParaRPr kumimoji="0" lang="en-US" sz="1800" b="0" i="0" u="none" strike="noStrike" kern="1200" cap="none" spc="0" normalizeH="0" baseline="0" noProof="0">
-              <a:ln>
-                <a:noFill/>
-              </a:ln>
-              <a:solidFill>
-                <a:prstClr val="white"/>
-              </a:solidFill>
-              <a:effectLst/>
-              <a:uLnTx/>
-              <a:uFillTx/>
-              <a:latin typeface="Century Gothic" panose="020B0502020202020204"/>
-              <a:ea typeface="+mn-ea"/>
-              <a:cs typeface="+mn-cs"/>
-            </a:endParaRPr>
-          </a:p>
-        </p:txBody>
-      </p:sp>
-      <p:pic>
-        <p:nvPicPr>
-          <p:cNvPr id="12" name="Picture 11">
-            <a:extLst>
-              <a:ext uri="{FF2B5EF4-FFF2-40B4-BE49-F238E27FC236}">
-                <a16:creationId xmlns:a16="http://schemas.microsoft.com/office/drawing/2014/main" id="{D2B93162-635C-46F5-97EC-E98C1659F1F0}"/>
-              </a:ext>
-              <a:ext uri="{C183D7F6-B498-43B3-948B-1728B52AA6E4}">
-                <adec:decorative xmlns:adec="http://schemas.microsoft.com/office/drawing/2017/decorative" val="1"/>
-              </a:ext>
-            </a:extLst>
-          </p:cNvPr>
-          <p:cNvPicPr>
-            <a:picLocks noGrp="1" noRot="1" noChangeAspect="1" noMove="1" noResize="1" noEditPoints="1" noAdjustHandles="1" noChangeArrowheads="1" noChangeShapeType="1" noCrop="1"/>
-          </p:cNvPicPr>
-          <p:nvPr>
-            <p:extLst>
-              <p:ext uri="{386F3935-93C4-4BCD-93E2-E3B085C9AB24}">
-                <p16:designElem xmlns:p16="http://schemas.microsoft.com/office/powerpoint/2015/main" val="1"/>
-              </p:ext>
-            </p:extLst>
-          </p:nvPr>
-        </p:nvPicPr>
-        <p:blipFill rotWithShape="1">
-          <a:blip r:embed="rId2">
-            <a:extLst>
-              <a:ext uri="{28A0092B-C50C-407E-A947-70E740481C1C}">
-                <a14:useLocalDpi xmlns:a14="http://schemas.microsoft.com/office/drawing/2010/main" val="0"/>
-              </a:ext>
-            </a:extLst>
-          </a:blip>
-          <a:srcRect r="61975"/>
-          <a:stretch/>
-        </p:blipFill>
-        <p:spPr>
-          <a:xfrm>
-            <a:off x="0" y="4375150"/>
-            <a:ext cx="3477006" cy="2482850"/>
-          </a:xfrm>
-          <a:prstGeom prst="rect">
-            <a:avLst/>
-          </a:prstGeom>
-        </p:spPr>
-      </p:pic>
-      <p:sp>
-        <p:nvSpPr>
-          <p:cNvPr id="2" name="Title 1"/>
-          <p:cNvSpPr>
-            <a:spLocks noGrp="1"/>
-          </p:cNvSpPr>
-          <p:nvPr>
-            <p:ph type="title"/>
-          </p:nvPr>
-        </p:nvSpPr>
-        <p:spPr>
-          <a:xfrm>
-            <a:off x="499441" y="987287"/>
-            <a:ext cx="2661202" cy="4697896"/>
-          </a:xfrm>
-        </p:spPr>
-        <p:txBody>
-          <a:bodyPr>
-            <a:normAutofit/>
-          </a:bodyPr>
-          <a:lstStyle/>
-          <a:p>
-            <a:r>
-              <a:rPr lang="es-AR" sz="2900"/>
-              <a:t>Conclusión</a:t>
-            </a:r>
-          </a:p>
-        </p:txBody>
-      </p:sp>
-      <p:sp>
-        <p:nvSpPr>
-          <p:cNvPr id="3" name="Content Placeholder 2"/>
-          <p:cNvSpPr>
-            <a:spLocks noGrp="1"/>
-          </p:cNvSpPr>
-          <p:nvPr>
-            <p:ph idx="1"/>
-          </p:nvPr>
-        </p:nvSpPr>
-        <p:spPr>
-          <a:xfrm>
-            <a:off x="3793368" y="987287"/>
-            <a:ext cx="4316962" cy="4697895"/>
-          </a:xfrm>
-        </p:spPr>
-        <p:txBody>
-          <a:bodyPr anchor="ctr">
-            <a:normAutofit/>
-          </a:bodyPr>
-          <a:lstStyle/>
-          <a:p>
-            <a:r>
-              <a:rPr lang="es-ES" sz="1600"/>
-              <a:t>• Se logró modelar el funcionamiento completo de una fábrica automotriz.</a:t>
-            </a:r>
-          </a:p>
-          <a:p>
-            <a:r>
-              <a:rPr lang="es-ES" sz="1600"/>
-              <a:t>• Se aplicaron conceptos de bases de datos, ABM y consultas SQL.</a:t>
-            </a:r>
-          </a:p>
-          <a:p>
-            <a:r>
-              <a:rPr lang="es-ES" sz="1600"/>
-              <a:t>• Buen trabajo en equipo entre Word, SQL y PowerPoint.</a:t>
-            </a:r>
-          </a:p>
-        </p:txBody>
-      </p:sp>
-    </p:spTree>
-  </p:cSld>
-  <p:clrMapOvr>
-    <a:masterClrMapping/>
-  </p:clrMapOvr>
-</p:sld>
-</file>
-
-<file path=ppt/slides/slide9.xml><?xml version="1.0" encoding="utf-8"?>
-<p:sld xmlns:a="http://schemas.openxmlformats.org/drawingml/2006/main" xmlns:r="http://schemas.openxmlformats.org/officeDocument/2006/relationships" xmlns:p="http://schemas.openxmlformats.org/presentationml/2006/main">
-  <p:cSld>
     <p:spTree>
       <p:nvGrpSpPr>
         <p:cNvPr id="1" name=""/>
@@ -27900,6 +28115,98 @@
     <p:extLst>
       <p:ext uri="{BB962C8B-B14F-4D97-AF65-F5344CB8AC3E}">
         <p14:creationId xmlns:p14="http://schemas.microsoft.com/office/powerpoint/2010/main" val="2530186683"/>
+      </p:ext>
+    </p:extLst>
+  </p:cSld>
+  <p:clrMapOvr>
+    <a:masterClrMapping/>
+  </p:clrMapOvr>
+</p:sld>
+</file>
+
+<file path=ppt/slides/slide9.xml><?xml version="1.0" encoding="utf-8"?>
+<p:sld xmlns:a="http://schemas.openxmlformats.org/drawingml/2006/main" xmlns:r="http://schemas.openxmlformats.org/officeDocument/2006/relationships" xmlns:p="http://schemas.openxmlformats.org/presentationml/2006/main">
+  <p:cSld>
+    <p:spTree>
+      <p:nvGrpSpPr>
+        <p:cNvPr id="1" name=""/>
+        <p:cNvGrpSpPr/>
+        <p:nvPr/>
+      </p:nvGrpSpPr>
+      <p:grpSpPr>
+        <a:xfrm>
+          <a:off x="0" y="0"/>
+          <a:ext cx="0" cy="0"/>
+          <a:chOff x="0" y="0"/>
+          <a:chExt cx="0" cy="0"/>
+        </a:xfrm>
+      </p:grpSpPr>
+      <p:sp>
+        <p:nvSpPr>
+          <p:cNvPr id="2" name="Título 1">
+            <a:extLst>
+              <a:ext uri="{FF2B5EF4-FFF2-40B4-BE49-F238E27FC236}">
+                <a16:creationId xmlns:a16="http://schemas.microsoft.com/office/drawing/2014/main" id="{FAEA1BBB-E101-2ABB-8D02-1C9807851817}"/>
+              </a:ext>
+            </a:extLst>
+          </p:cNvPr>
+          <p:cNvSpPr>
+            <a:spLocks noGrp="1"/>
+          </p:cNvSpPr>
+          <p:nvPr>
+            <p:ph type="title"/>
+          </p:nvPr>
+        </p:nvSpPr>
+        <p:spPr/>
+        <p:txBody>
+          <a:bodyPr/>
+          <a:lstStyle/>
+          <a:p>
+            <a:pPr algn="ctr"/>
+            <a:r>
+              <a:rPr lang="es-ES" dirty="0" err="1"/>
+              <a:t>procedure</a:t>
+            </a:r>
+            <a:endParaRPr lang="es-AR" dirty="0"/>
+          </a:p>
+        </p:txBody>
+      </p:sp>
+      <p:pic>
+        <p:nvPicPr>
+          <p:cNvPr id="5" name="Marcador de contenido 4">
+            <a:extLst>
+              <a:ext uri="{FF2B5EF4-FFF2-40B4-BE49-F238E27FC236}">
+                <a16:creationId xmlns:a16="http://schemas.microsoft.com/office/drawing/2014/main" id="{89A27943-D176-EC25-6EDD-A3099ABC3E2C}"/>
+              </a:ext>
+            </a:extLst>
+          </p:cNvPr>
+          <p:cNvPicPr>
+            <a:picLocks noGrp="1" noChangeAspect="1"/>
+          </p:cNvPicPr>
+          <p:nvPr>
+            <p:ph idx="1"/>
+          </p:nvPr>
+        </p:nvPicPr>
+        <p:blipFill>
+          <a:blip r:embed="rId2"/>
+          <a:stretch>
+            <a:fillRect/>
+          </a:stretch>
+        </p:blipFill>
+        <p:spPr>
+          <a:xfrm>
+            <a:off x="1447800" y="2305050"/>
+            <a:ext cx="6248400" cy="3848100"/>
+          </a:xfrm>
+          <a:prstGeom prst="rect">
+            <a:avLst/>
+          </a:prstGeom>
+        </p:spPr>
+      </p:pic>
+    </p:spTree>
+    <p:extLst>
+      <p:ext uri="{BB962C8B-B14F-4D97-AF65-F5344CB8AC3E}">
+        <p14:creationId xmlns:p14="http://schemas.microsoft.com/office/powerpoint/2010/main" val="1809458920"/>
       </p:ext>
     </p:extLst>
   </p:cSld>

</xml_diff>